<commit_message>
initial IETF 125 slides
</commit_message>
<xml_diff>
--- a/ietf124-Montreal/Slides/OPS-WG-Updates-IPPM-PERFMETRDIR.pptx
+++ b/ietf124-Montreal/Slides/OPS-WG-Updates-IPPM-PERFMETRDIR.pptx
@@ -116,6 +116,14 @@
 </p:presentation>
 </file>
 
+<file path=ppt/revisionInfo.xml><?xml version="1.0" encoding="utf-8"?>
+<p1510:revInfo xmlns:a="http://schemas.openxmlformats.org/drawingml/2006/main" xmlns:r="http://schemas.openxmlformats.org/officeDocument/2006/relationships" xmlns:p1510="http://schemas.microsoft.com/office/powerpoint/2015/10/main">
+  <p1510:revLst>
+    <p1510:client id="{814BA566-C6FD-4F83-B085-32E228DAD1BF}" v="1" dt="2026-03-08T09:52:28.901"/>
+  </p1510:revLst>
+</p1510:revInfo>
+</file>
+
 <file path=ppt/changesInfos/changesInfo1.xml><?xml version="1.0" encoding="utf-8"?>
 <pc:chgInfo xmlns:a="http://schemas.openxmlformats.org/drawingml/2006/main" xmlns:r="http://schemas.openxmlformats.org/officeDocument/2006/relationships" xmlns:ac="http://schemas.microsoft.com/office/drawing/2013/main/command" xmlns:pc="http://schemas.microsoft.com/office/powerpoint/2013/main/command">
   <pc:docChgLst>
@@ -131,8 +139,32 @@
           <pc:docMk/>
           <pc:sldMk cId="2180883231" sldId="258"/>
         </pc:sldMkLst>
+      </pc:sldChg>
+    </pc:docChg>
+  </pc:docChgLst>
+  <pc:docChgLst>
+    <pc:chgData name="Graf Thomas, SCS-INI-NET-VNC-E2E" userId="487bc3e3-9ce7-4cdd-b7b4-8899ea88d289" providerId="ADAL" clId="{ADEEF08A-D719-4B50-A383-4105EDA2C206}"/>
+    <pc:docChg chg="custSel modSld">
+      <pc:chgData name="Graf Thomas, SCS-INI-NET-VNC-E2E" userId="487bc3e3-9ce7-4cdd-b7b4-8899ea88d289" providerId="ADAL" clId="{ADEEF08A-D719-4B50-A383-4105EDA2C206}" dt="2026-03-08T10:05:21.666" v="30" actId="27636"/>
+      <pc:docMkLst>
+        <pc:docMk/>
+      </pc:docMkLst>
+      <pc:sldChg chg="modSp mod">
+        <pc:chgData name="Graf Thomas, SCS-INI-NET-VNC-E2E" userId="487bc3e3-9ce7-4cdd-b7b4-8899ea88d289" providerId="ADAL" clId="{ADEEF08A-D719-4B50-A383-4105EDA2C206}" dt="2026-03-08T10:05:21.666" v="30" actId="27636"/>
+        <pc:sldMkLst>
+          <pc:docMk/>
+          <pc:sldMk cId="2180883231" sldId="258"/>
+        </pc:sldMkLst>
         <pc:spChg chg="mod">
-          <ac:chgData name="Marcus Ihlar" userId="3466507a-8f95-47f2-ae1b-ce7d6ca611a4" providerId="ADAL" clId="{3438F4FC-D214-4A35-B915-405844213C8B}" dt="2025-11-04T14:52:31.633" v="8" actId="20577"/>
+          <ac:chgData name="Graf Thomas, SCS-INI-NET-VNC-E2E" userId="487bc3e3-9ce7-4cdd-b7b4-8899ea88d289" providerId="ADAL" clId="{ADEEF08A-D719-4B50-A383-4105EDA2C206}" dt="2026-03-08T10:05:17.894" v="28" actId="20577"/>
+          <ac:spMkLst>
+            <pc:docMk/>
+            <pc:sldMk cId="2180883231" sldId="258"/>
+            <ac:spMk id="2" creationId="{6841F4A8-32C7-087F-ADC5-EC992FA45176}"/>
+          </ac:spMkLst>
+        </pc:spChg>
+        <pc:spChg chg="mod">
+          <ac:chgData name="Graf Thomas, SCS-INI-NET-VNC-E2E" userId="487bc3e3-9ce7-4cdd-b7b4-8899ea88d289" providerId="ADAL" clId="{ADEEF08A-D719-4B50-A383-4105EDA2C206}" dt="2026-03-08T10:05:21.666" v="30" actId="27636"/>
           <ac:spMkLst>
             <pc:docMk/>
             <pc:sldMk cId="2180883231" sldId="258"/>
@@ -227,7 +259,7 @@
           <a:p>
             <a:fld id="{993813BE-9644-4EB0-A6C4-0B9517916EF9}" type="datetimeFigureOut">
               <a:rPr lang="fr-FR" smtClean="0"/>
-              <a:t>04/11/2025</a:t>
+              <a:t>08/03/2026</a:t>
             </a:fld>
             <a:endParaRPr lang="fr-FR" dirty="0"/>
           </a:p>
@@ -809,7 +841,7 @@
           <a:p>
             <a:fld id="{AF3A2D09-215D-4610-87DE-176F93FAFFFB}" type="datetime1">
               <a:rPr lang="fr-FR" smtClean="0"/>
-              <a:t>04/11/2025</a:t>
+              <a:t>08/03/2026</a:t>
             </a:fld>
             <a:endParaRPr lang="fr-FR" dirty="0"/>
           </a:p>
@@ -1011,7 +1043,7 @@
           <a:p>
             <a:fld id="{7F2B3DBA-070E-4070-BF49-61ED05E982A8}" type="datetime1">
               <a:rPr lang="fr-FR" smtClean="0"/>
-              <a:t>04/11/2025</a:t>
+              <a:t>08/03/2026</a:t>
             </a:fld>
             <a:endParaRPr lang="fr-FR" dirty="0"/>
           </a:p>
@@ -1223,7 +1255,7 @@
           <a:p>
             <a:fld id="{1861926C-C024-4DC6-8C34-EC76F14394CD}" type="datetime1">
               <a:rPr lang="fr-FR" smtClean="0"/>
-              <a:t>04/11/2025</a:t>
+              <a:t>08/03/2026</a:t>
             </a:fld>
             <a:endParaRPr lang="fr-FR" dirty="0"/>
           </a:p>
@@ -1425,7 +1457,7 @@
           <a:p>
             <a:fld id="{1FEACCCC-DFCC-4756-9119-F1F4182DEE79}" type="datetime1">
               <a:rPr lang="fr-FR" smtClean="0"/>
-              <a:t>04/11/2025</a:t>
+              <a:t>08/03/2026</a:t>
             </a:fld>
             <a:endParaRPr lang="fr-FR" dirty="0"/>
           </a:p>
@@ -1704,7 +1736,7 @@
           <a:p>
             <a:fld id="{F166DA53-6888-4012-9540-B1A2D306F057}" type="datetime1">
               <a:rPr lang="fr-FR" smtClean="0"/>
-              <a:t>04/11/2025</a:t>
+              <a:t>08/03/2026</a:t>
             </a:fld>
             <a:endParaRPr lang="fr-FR" dirty="0"/>
           </a:p>
@@ -1973,7 +2005,7 @@
           <a:p>
             <a:fld id="{B2712EA3-61AF-4B68-96B7-FD0EF5B6D1CF}" type="datetime1">
               <a:rPr lang="fr-FR" smtClean="0"/>
-              <a:t>04/11/2025</a:t>
+              <a:t>08/03/2026</a:t>
             </a:fld>
             <a:endParaRPr lang="fr-FR" dirty="0"/>
           </a:p>
@@ -2389,7 +2421,7 @@
           <a:p>
             <a:fld id="{397F3E34-6190-4D3B-AA13-9C745685F55B}" type="datetime1">
               <a:rPr lang="fr-FR" smtClean="0"/>
-              <a:t>04/11/2025</a:t>
+              <a:t>08/03/2026</a:t>
             </a:fld>
             <a:endParaRPr lang="fr-FR" dirty="0"/>
           </a:p>
@@ -2534,7 +2566,7 @@
           <a:p>
             <a:fld id="{16A0672A-08CA-4958-B194-97B82EC017A1}" type="datetime1">
               <a:rPr lang="fr-FR" smtClean="0"/>
-              <a:t>04/11/2025</a:t>
+              <a:t>08/03/2026</a:t>
             </a:fld>
             <a:endParaRPr lang="fr-FR" dirty="0"/>
           </a:p>
@@ -2651,7 +2683,7 @@
           <a:p>
             <a:fld id="{716B3D01-0A26-4955-A3B9-82886643D6B4}" type="datetime1">
               <a:rPr lang="fr-FR" smtClean="0"/>
-              <a:t>04/11/2025</a:t>
+              <a:t>08/03/2026</a:t>
             </a:fld>
             <a:endParaRPr lang="fr-FR" dirty="0"/>
           </a:p>
@@ -2966,7 +2998,7 @@
           <a:p>
             <a:fld id="{13A4B2D0-68E8-43E1-BC8F-2FA077EAE1FE}" type="datetime1">
               <a:rPr lang="fr-FR" smtClean="0"/>
-              <a:t>04/11/2025</a:t>
+              <a:t>08/03/2026</a:t>
             </a:fld>
             <a:endParaRPr lang="fr-FR" dirty="0"/>
           </a:p>
@@ -3258,7 +3290,7 @@
           <a:p>
             <a:fld id="{631352CE-85DA-4448-A952-A5096EB6C4CB}" type="datetime1">
               <a:rPr lang="fr-FR" smtClean="0"/>
-              <a:t>04/11/2025</a:t>
+              <a:t>08/03/2026</a:t>
             </a:fld>
             <a:endParaRPr lang="fr-FR" dirty="0"/>
           </a:p>
@@ -3503,7 +3535,7 @@
           <a:p>
             <a:fld id="{CBB112E7-EB8B-4390-BCC3-B52E854F5AF2}" type="datetime1">
               <a:rPr lang="fr-FR" smtClean="0"/>
-              <a:t>04/11/2025</a:t>
+              <a:t>08/03/2026</a:t>
             </a:fld>
             <a:endParaRPr lang="fr-FR" dirty="0"/>
           </a:p>
@@ -3948,7 +3980,7 @@
           <a:p>
             <a:r>
               <a:rPr lang="de-CH" dirty="0"/>
-              <a:t>IP Performance Measurement (IPPM) </a:t>
+              <a:t>IP Performance Measurement (IPPM)</a:t>
             </a:r>
             <a:endParaRPr lang="fr-FR" dirty="0"/>
           </a:p>
@@ -3972,13 +4004,13 @@
         </p:nvSpPr>
         <p:spPr>
           <a:xfrm>
-            <a:off x="838200" y="1627332"/>
-            <a:ext cx="10515600" cy="4729018"/>
+            <a:off x="838200" y="1690688"/>
+            <a:ext cx="10515600" cy="4665661"/>
           </a:xfrm>
         </p:spPr>
         <p:txBody>
           <a:bodyPr numCol="2">
-            <a:normAutofit fontScale="85000" lnSpcReduction="20000"/>
+            <a:normAutofit fontScale="77500" lnSpcReduction="20000"/>
           </a:bodyPr>
           <a:lstStyle/>
           <a:p>
@@ -4288,11 +4320,11 @@
             </a:r>
             <a:r>
               <a:rPr lang="en-US" b="1" dirty="0"/>
-              <a:t>-</a:t>
+              <a:t>-ippm-</a:t>
             </a:r>
             <a:r>
               <a:rPr lang="en-US" b="1" dirty="0" err="1"/>
-              <a:t>ippm-qoo</a:t>
+              <a:t>qoo</a:t>
             </a:r>
             <a:r>
               <a:rPr lang="en-US" b="1" dirty="0"/>
@@ -4300,15 +4332,7 @@
             </a:r>
             <a:r>
               <a:rPr lang="en-US" dirty="0"/>
-              <a:t>passed working group last </a:t>
-            </a:r>
-            <a:r>
-              <a:rPr lang="en-US"/>
-              <a:t>call and submitted </a:t>
-            </a:r>
-            <a:r>
-              <a:rPr lang="en-US" dirty="0"/>
-              <a:t>to IESG.</a:t>
+              <a:t>passed working group last call and submitted to IESG.</a:t>
             </a:r>
           </a:p>
           <a:p>

</xml_diff>